<commit_message>
Complete SignSpeak AI v1.0: HF ArSL data, trained models, single-port UI.
Fetch ArSL2018 from Hugging Face, train MLP and MobileNet checkpoints,
add evaluation charts, regenerate report/slides, and serve the Next.js
frontend and FastAPI backend together on port 8000 via run_app.ps1.
</commit_message>
<xml_diff>
--- a/slides/SignSpeak_AI_Defence.pptx
+++ b/slides/SignSpeak_AI_Defence.pptx
@@ -4451,39 +4451,317 @@
           </a:p>
         </p:txBody>
       </p:sp>
-      <p:sp>
-        <p:nvSpPr>
-          <p:cNvPr id="4" name="TextBox 3"/>
-          <p:cNvSpPr txBox="1"/>
+      <p:graphicFrame>
+        <p:nvGraphicFramePr>
+          <p:cNvPr id="4" name="Table 3"/>
+          <p:cNvGraphicFramePr>
+            <a:graphicFrameLocks noGrp="1"/>
+          </p:cNvGraphicFramePr>
           <p:nvPr/>
-        </p:nvSpPr>
-        <p:spPr>
-          <a:xfrm>
-            <a:off x="900000" y="1260000"/>
-            <a:ext cx="7920000" cy="1440000"/>
+        </p:nvGraphicFramePr>
+        <p:xfrm>
+          <a:off x="900000" y="1260000"/>
+          <a:ext cx="7920000" cy="1440000"/>
+        </p:xfrm>
+        <a:graphic>
+          <a:graphicData uri="http://schemas.openxmlformats.org/drawingml/2006/table">
+            <a:tbl>
+              <a:tblPr firstRow="1" bandRow="1">
+                <a:tableStyleId>{5C22544A-7EE6-4342-B048-85BDC9FD1C3A}</a:tableStyleId>
+              </a:tblPr>
+              <a:tblGrid>
+                <a:gridCol w="2640000"/>
+                <a:gridCol w="2640000"/>
+                <a:gridCol w="2640000"/>
+              </a:tblGrid>
+              <a:tr h="360000">
+                <a:tc>
+                  <a:txBody>
+                    <a:bodyPr wrap="square"/>
+                    <a:lstStyle/>
+                    <a:p>
+                      <a:r>
+                        <a:rPr sz="1100" b="1">
+                          <a:solidFill>
+                            <a:srgbClr val="F8FAFC"/>
+                          </a:solidFill>
+                        </a:rPr>
+                        <a:t>Subset</a:t>
+                      </a:r>
+                    </a:p>
+                  </a:txBody>
+                  <a:tcPr>
+                    <a:solidFill>
+                      <a:srgbClr val="1E293B"/>
+                    </a:solidFill>
+                  </a:tcPr>
+                </a:tc>
+                <a:tc>
+                  <a:txBody>
+                    <a:bodyPr wrap="square"/>
+                    <a:lstStyle/>
+                    <a:p>
+                      <a:r>
+                        <a:rPr sz="1100" b="1">
+                          <a:solidFill>
+                            <a:srgbClr val="F8FAFC"/>
+                          </a:solidFill>
+                        </a:rPr>
+                        <a:t>Accuracy</a:t>
+                      </a:r>
+                    </a:p>
+                  </a:txBody>
+                  <a:tcPr>
+                    <a:solidFill>
+                      <a:srgbClr val="1E293B"/>
+                    </a:solidFill>
+                  </a:tcPr>
+                </a:tc>
+                <a:tc>
+                  <a:txBody>
+                    <a:bodyPr wrap="square"/>
+                    <a:lstStyle/>
+                    <a:p>
+                      <a:r>
+                        <a:rPr sz="1100" b="1">
+                          <a:solidFill>
+                            <a:srgbClr val="F8FAFC"/>
+                          </a:solidFill>
+                        </a:rPr>
+                        <a:t>N</a:t>
+                      </a:r>
+                    </a:p>
+                  </a:txBody>
+                  <a:tcPr>
+                    <a:solidFill>
+                      <a:srgbClr val="1E293B"/>
+                    </a:solidFill>
+                  </a:tcPr>
+                </a:tc>
+              </a:tr>
+              <a:tr h="360000">
+                <a:tc>
+                  <a:txBody>
+                    <a:bodyPr wrap="square"/>
+                    <a:lstStyle/>
+                    <a:p>
+                      <a:r>
+                        <a:rPr sz="1100" b="0">
+                          <a:solidFill>
+                            <a:srgbClr val="F8FAFC"/>
+                          </a:solidFill>
+                        </a:rPr>
+                        <a:t>Overall (ASL + ArSL)</a:t>
+                      </a:r>
+                    </a:p>
+                  </a:txBody>
+                  <a:tcPr>
+                    <a:solidFill>
+                      <a:srgbClr val="0F172A"/>
+                    </a:solidFill>
+                  </a:tcPr>
+                </a:tc>
+                <a:tc>
+                  <a:txBody>
+                    <a:bodyPr wrap="square"/>
+                    <a:lstStyle/>
+                    <a:p>
+                      <a:r>
+                        <a:rPr sz="1100" b="0">
+                          <a:solidFill>
+                            <a:srgbClr val="F8FAFC"/>
+                          </a:solidFill>
+                        </a:rPr>
+                        <a:t>0.9888</a:t>
+                      </a:r>
+                    </a:p>
+                  </a:txBody>
+                  <a:tcPr>
+                    <a:solidFill>
+                      <a:srgbClr val="0F172A"/>
+                    </a:solidFill>
+                  </a:tcPr>
+                </a:tc>
+                <a:tc>
+                  <a:txBody>
+                    <a:bodyPr wrap="square"/>
+                    <a:lstStyle/>
+                    <a:p>
+                      <a:r>
+                        <a:rPr sz="1100" b="0">
+                          <a:solidFill>
+                            <a:srgbClr val="F8FAFC"/>
+                          </a:solidFill>
+                        </a:rPr>
+                        <a:t>1431</a:t>
+                      </a:r>
+                    </a:p>
+                  </a:txBody>
+                  <a:tcPr>
+                    <a:solidFill>
+                      <a:srgbClr val="0F172A"/>
+                    </a:solidFill>
+                  </a:tcPr>
+                </a:tc>
+              </a:tr>
+              <a:tr h="360000">
+                <a:tc>
+                  <a:txBody>
+                    <a:bodyPr wrap="square"/>
+                    <a:lstStyle/>
+                    <a:p>
+                      <a:r>
+                        <a:rPr sz="1100" b="0">
+                          <a:solidFill>
+                            <a:srgbClr val="F8FAFC"/>
+                          </a:solidFill>
+                        </a:rPr>
+                        <a:t>ASL only</a:t>
+                      </a:r>
+                    </a:p>
+                  </a:txBody>
+                  <a:tcPr>
+                    <a:solidFill>
+                      <a:srgbClr val="0F172A"/>
+                    </a:solidFill>
+                  </a:tcPr>
+                </a:tc>
+                <a:tc>
+                  <a:txBody>
+                    <a:bodyPr wrap="square"/>
+                    <a:lstStyle/>
+                    <a:p>
+                      <a:r>
+                        <a:rPr sz="1100" b="0">
+                          <a:solidFill>
+                            <a:srgbClr val="F8FAFC"/>
+                          </a:solidFill>
+                        </a:rPr>
+                        <a:t>0.9930</a:t>
+                      </a:r>
+                    </a:p>
+                  </a:txBody>
+                  <a:tcPr>
+                    <a:solidFill>
+                      <a:srgbClr val="0F172A"/>
+                    </a:solidFill>
+                  </a:tcPr>
+                </a:tc>
+                <a:tc>
+                  <a:txBody>
+                    <a:bodyPr wrap="square"/>
+                    <a:lstStyle/>
+                    <a:p>
+                      <a:r>
+                        <a:rPr sz="1100" b="0">
+                          <a:solidFill>
+                            <a:srgbClr val="F8FAFC"/>
+                          </a:solidFill>
+                        </a:rPr>
+                        <a:t>1421</a:t>
+                      </a:r>
+                    </a:p>
+                  </a:txBody>
+                  <a:tcPr>
+                    <a:solidFill>
+                      <a:srgbClr val="0F172A"/>
+                    </a:solidFill>
+                  </a:tcPr>
+                </a:tc>
+              </a:tr>
+              <a:tr h="360000">
+                <a:tc>
+                  <a:txBody>
+                    <a:bodyPr wrap="square"/>
+                    <a:lstStyle/>
+                    <a:p>
+                      <a:r>
+                        <a:rPr sz="1100" b="0">
+                          <a:solidFill>
+                            <a:srgbClr val="F8FAFC"/>
+                          </a:solidFill>
+                        </a:rPr>
+                        <a:t>ArSL only</a:t>
+                      </a:r>
+                    </a:p>
+                  </a:txBody>
+                  <a:tcPr>
+                    <a:solidFill>
+                      <a:srgbClr val="0F172A"/>
+                    </a:solidFill>
+                  </a:tcPr>
+                </a:tc>
+                <a:tc>
+                  <a:txBody>
+                    <a:bodyPr wrap="square"/>
+                    <a:lstStyle/>
+                    <a:p>
+                      <a:r>
+                        <a:rPr sz="1100" b="0">
+                          <a:solidFill>
+                            <a:srgbClr val="F8FAFC"/>
+                          </a:solidFill>
+                        </a:rPr>
+                        <a:t>0.4000</a:t>
+                      </a:r>
+                    </a:p>
+                  </a:txBody>
+                  <a:tcPr>
+                    <a:solidFill>
+                      <a:srgbClr val="0F172A"/>
+                    </a:solidFill>
+                  </a:tcPr>
+                </a:tc>
+                <a:tc>
+                  <a:txBody>
+                    <a:bodyPr wrap="square"/>
+                    <a:lstStyle/>
+                    <a:p>
+                      <a:r>
+                        <a:rPr sz="1100" b="0">
+                          <a:solidFill>
+                            <a:srgbClr val="F8FAFC"/>
+                          </a:solidFill>
+                        </a:rPr>
+                        <a:t>10</a:t>
+                      </a:r>
+                    </a:p>
+                  </a:txBody>
+                  <a:tcPr>
+                    <a:solidFill>
+                      <a:srgbClr val="0F172A"/>
+                    </a:solidFill>
+                  </a:tcPr>
+                </a:tc>
+              </a:tr>
+            </a:tbl>
+          </a:graphicData>
+        </a:graphic>
+      </p:graphicFrame>
+      <p:pic>
+        <p:nvPicPr>
+          <p:cNvPr id="5" name="Picture 4" descr="training_curves.png"/>
+          <p:cNvPicPr>
+            <a:picLocks noChangeAspect="1"/>
+          </p:cNvPicPr>
+          <p:nvPr/>
+        </p:nvPicPr>
+        <p:blipFill>
+          <a:blip r:embed="rId2"/>
+          <a:stretch>
+            <a:fillRect/>
+          </a:stretch>
+        </p:blipFill>
+        <p:spPr>
+          <a:xfrm>
+            <a:off x="900000" y="2880000"/>
+            <a:ext cx="7920000" cy="2640000"/>
           </a:xfrm>
           <a:prstGeom prst="rect">
             <a:avLst/>
           </a:prstGeom>
-          <a:noFill/>
-        </p:spPr>
-        <p:txBody>
-          <a:bodyPr wrap="square">
-            <a:spAutoFit/>
-          </a:bodyPr>
-          <a:lstStyle/>
-          <a:p>
-            <a:r>
-              <a:rPr sz="1400" b="0">
-                <a:solidFill>
-                  <a:srgbClr val="94A3B8"/>
-                </a:solidFill>
-              </a:rPr>
-              <a:t>[table to be inserted after training]</a:t>
-            </a:r>
-          </a:p>
-        </p:txBody>
-      </p:sp>
+        </p:spPr>
+      </p:pic>
     </p:spTree>
   </p:cSld>
   <p:clrMapOvr>
@@ -4586,6 +4864,54 @@
           </a:p>
         </p:txBody>
       </p:sp>
+      <p:pic>
+        <p:nvPicPr>
+          <p:cNvPr id="4" name="Picture 3" descr="confusion_matrix_asl.png"/>
+          <p:cNvPicPr>
+            <a:picLocks noChangeAspect="1"/>
+          </p:cNvPicPr>
+          <p:nvPr/>
+        </p:nvPicPr>
+        <p:blipFill>
+          <a:blip r:embed="rId2"/>
+          <a:stretch>
+            <a:fillRect/>
+          </a:stretch>
+        </p:blipFill>
+        <p:spPr>
+          <a:xfrm>
+            <a:off x="360000" y="1007999"/>
+            <a:ext cx="5040000" cy="4480000"/>
+          </a:xfrm>
+          <a:prstGeom prst="rect">
+            <a:avLst/>
+          </a:prstGeom>
+        </p:spPr>
+      </p:pic>
+      <p:pic>
+        <p:nvPicPr>
+          <p:cNvPr id="5" name="Picture 4" descr="confusion_matrix_arsl.png"/>
+          <p:cNvPicPr>
+            <a:picLocks noChangeAspect="1"/>
+          </p:cNvPicPr>
+          <p:nvPr/>
+        </p:nvPicPr>
+        <p:blipFill>
+          <a:blip r:embed="rId3"/>
+          <a:stretch>
+            <a:fillRect/>
+          </a:stretch>
+        </p:blipFill>
+        <p:spPr>
+          <a:xfrm>
+            <a:off x="5580000" y="1007999"/>
+            <a:ext cx="5040000" cy="4032000"/>
+          </a:xfrm>
+          <a:prstGeom prst="rect">
+            <a:avLst/>
+          </a:prstGeom>
+        </p:spPr>
+      </p:pic>
     </p:spTree>
   </p:cSld>
   <p:clrMapOvr>
@@ -4721,39 +5047,252 @@
           </a:p>
         </p:txBody>
       </p:sp>
-      <p:sp>
-        <p:nvSpPr>
-          <p:cNvPr id="5" name="TextBox 4"/>
-          <p:cNvSpPr txBox="1"/>
+      <p:graphicFrame>
+        <p:nvGraphicFramePr>
+          <p:cNvPr id="5" name="Table 4"/>
+          <p:cNvGraphicFramePr>
+            <a:graphicFrameLocks noGrp="1"/>
+          </p:cNvGraphicFramePr>
           <p:nvPr/>
-        </p:nvSpPr>
-        <p:spPr>
-          <a:xfrm>
-            <a:off x="900000" y="1440000"/>
-            <a:ext cx="3960000" cy="1440000"/>
-          </a:xfrm>
-          <a:prstGeom prst="rect">
-            <a:avLst/>
-          </a:prstGeom>
-          <a:noFill/>
-        </p:spPr>
-        <p:txBody>
-          <a:bodyPr wrap="square">
-            <a:spAutoFit/>
-          </a:bodyPr>
-          <a:lstStyle/>
-          <a:p>
-            <a:r>
-              <a:rPr sz="1400" b="0">
-                <a:solidFill>
-                  <a:srgbClr val="94A3B8"/>
-                </a:solidFill>
-              </a:rPr>
-              <a:t>[table to be inserted after training]</a:t>
-            </a:r>
-          </a:p>
-        </p:txBody>
-      </p:sp>
+        </p:nvGraphicFramePr>
+        <p:xfrm>
+          <a:off x="900000" y="1440000"/>
+          <a:ext cx="3960000" cy="1440000"/>
+        </p:xfrm>
+        <a:graphic>
+          <a:graphicData uri="http://schemas.openxmlformats.org/drawingml/2006/table">
+            <a:tbl>
+              <a:tblPr firstRow="1" bandRow="1">
+                <a:tableStyleId>{5C22544A-7EE6-4342-B048-85BDC9FD1C3A}</a:tableStyleId>
+              </a:tblPr>
+              <a:tblGrid>
+                <a:gridCol w="1980000"/>
+                <a:gridCol w="1980000"/>
+              </a:tblGrid>
+              <a:tr h="288000">
+                <a:tc>
+                  <a:txBody>
+                    <a:bodyPr wrap="square"/>
+                    <a:lstStyle/>
+                    <a:p>
+                      <a:r>
+                        <a:rPr sz="1100" b="1">
+                          <a:solidFill>
+                            <a:srgbClr val="F8FAFC"/>
+                          </a:solidFill>
+                        </a:rPr>
+                        <a:t>Metric</a:t>
+                      </a:r>
+                    </a:p>
+                  </a:txBody>
+                  <a:tcPr>
+                    <a:solidFill>
+                      <a:srgbClr val="1E293B"/>
+                    </a:solidFill>
+                  </a:tcPr>
+                </a:tc>
+                <a:tc>
+                  <a:txBody>
+                    <a:bodyPr wrap="square"/>
+                    <a:lstStyle/>
+                    <a:p>
+                      <a:r>
+                        <a:rPr sz="1100" b="1">
+                          <a:solidFill>
+                            <a:srgbClr val="F8FAFC"/>
+                          </a:solidFill>
+                        </a:rPr>
+                        <a:t>Value</a:t>
+                      </a:r>
+                    </a:p>
+                  </a:txBody>
+                  <a:tcPr>
+                    <a:solidFill>
+                      <a:srgbClr val="1E293B"/>
+                    </a:solidFill>
+                  </a:tcPr>
+                </a:tc>
+              </a:tr>
+              <a:tr h="288000">
+                <a:tc>
+                  <a:txBody>
+                    <a:bodyPr wrap="square"/>
+                    <a:lstStyle/>
+                    <a:p>
+                      <a:r>
+                        <a:rPr sz="1100" b="0">
+                          <a:solidFill>
+                            <a:srgbClr val="F8FAFC"/>
+                          </a:solidFill>
+                        </a:rPr>
+                        <a:t>Mean latency ms</a:t>
+                      </a:r>
+                    </a:p>
+                  </a:txBody>
+                  <a:tcPr>
+                    <a:solidFill>
+                      <a:srgbClr val="0F172A"/>
+                    </a:solidFill>
+                  </a:tcPr>
+                </a:tc>
+                <a:tc>
+                  <a:txBody>
+                    <a:bodyPr wrap="square"/>
+                    <a:lstStyle/>
+                    <a:p>
+                      <a:r>
+                        <a:rPr sz="1100" b="0">
+                          <a:solidFill>
+                            <a:srgbClr val="F8FAFC"/>
+                          </a:solidFill>
+                        </a:rPr>
+                        <a:t>42.28</a:t>
+                      </a:r>
+                    </a:p>
+                  </a:txBody>
+                  <a:tcPr>
+                    <a:solidFill>
+                      <a:srgbClr val="0F172A"/>
+                    </a:solidFill>
+                  </a:tcPr>
+                </a:tc>
+              </a:tr>
+              <a:tr h="288000">
+                <a:tc>
+                  <a:txBody>
+                    <a:bodyPr wrap="square"/>
+                    <a:lstStyle/>
+                    <a:p>
+                      <a:r>
+                        <a:rPr sz="1100" b="0">
+                          <a:solidFill>
+                            <a:srgbClr val="F8FAFC"/>
+                          </a:solidFill>
+                        </a:rPr>
+                        <a:t>P95 latency ms</a:t>
+                      </a:r>
+                    </a:p>
+                  </a:txBody>
+                  <a:tcPr>
+                    <a:solidFill>
+                      <a:srgbClr val="0F172A"/>
+                    </a:solidFill>
+                  </a:tcPr>
+                </a:tc>
+                <a:tc>
+                  <a:txBody>
+                    <a:bodyPr wrap="square"/>
+                    <a:lstStyle/>
+                    <a:p>
+                      <a:r>
+                        <a:rPr sz="1100" b="0">
+                          <a:solidFill>
+                            <a:srgbClr val="F8FAFC"/>
+                          </a:solidFill>
+                        </a:rPr>
+                        <a:t>73.26</a:t>
+                      </a:r>
+                    </a:p>
+                  </a:txBody>
+                  <a:tcPr>
+                    <a:solidFill>
+                      <a:srgbClr val="0F172A"/>
+                    </a:solidFill>
+                  </a:tcPr>
+                </a:tc>
+              </a:tr>
+              <a:tr h="288000">
+                <a:tc>
+                  <a:txBody>
+                    <a:bodyPr wrap="square"/>
+                    <a:lstStyle/>
+                    <a:p>
+                      <a:r>
+                        <a:rPr sz="1100" b="0">
+                          <a:solidFill>
+                            <a:srgbClr val="F8FAFC"/>
+                          </a:solidFill>
+                        </a:rPr>
+                        <a:t>FPS (sustained)</a:t>
+                      </a:r>
+                    </a:p>
+                  </a:txBody>
+                  <a:tcPr>
+                    <a:solidFill>
+                      <a:srgbClr val="0F172A"/>
+                    </a:solidFill>
+                  </a:tcPr>
+                </a:tc>
+                <a:tc>
+                  <a:txBody>
+                    <a:bodyPr wrap="square"/>
+                    <a:lstStyle/>
+                    <a:p>
+                      <a:r>
+                        <a:rPr sz="1100" b="0">
+                          <a:solidFill>
+                            <a:srgbClr val="F8FAFC"/>
+                          </a:solidFill>
+                        </a:rPr>
+                        <a:t>23.65</a:t>
+                      </a:r>
+                    </a:p>
+                  </a:txBody>
+                  <a:tcPr>
+                    <a:solidFill>
+                      <a:srgbClr val="0F172A"/>
+                    </a:solidFill>
+                  </a:tcPr>
+                </a:tc>
+              </a:tr>
+              <a:tr h="288000">
+                <a:tc>
+                  <a:txBody>
+                    <a:bodyPr wrap="square"/>
+                    <a:lstStyle/>
+                    <a:p>
+                      <a:r>
+                        <a:rPr sz="1100" b="0">
+                          <a:solidFill>
+                            <a:srgbClr val="F8FAFC"/>
+                          </a:solidFill>
+                        </a:rPr>
+                        <a:t>Frames measured</a:t>
+                      </a:r>
+                    </a:p>
+                  </a:txBody>
+                  <a:tcPr>
+                    <a:solidFill>
+                      <a:srgbClr val="0F172A"/>
+                    </a:solidFill>
+                  </a:tcPr>
+                </a:tc>
+                <a:tc>
+                  <a:txBody>
+                    <a:bodyPr wrap="square"/>
+                    <a:lstStyle/>
+                    <a:p>
+                      <a:r>
+                        <a:rPr sz="1100" b="0">
+                          <a:solidFill>
+                            <a:srgbClr val="F8FAFC"/>
+                          </a:solidFill>
+                        </a:rPr>
+                        <a:t>30</a:t>
+                      </a:r>
+                    </a:p>
+                  </a:txBody>
+                  <a:tcPr>
+                    <a:solidFill>
+                      <a:srgbClr val="0F172A"/>
+                    </a:solidFill>
+                  </a:tcPr>
+                </a:tc>
+              </a:tr>
+            </a:tbl>
+          </a:graphicData>
+        </a:graphic>
+      </p:graphicFrame>
       <p:sp>
         <p:nvSpPr>
           <p:cNvPr id="6" name="TextBox 5"/>
@@ -4787,39 +5326,208 @@
           </a:p>
         </p:txBody>
       </p:sp>
-      <p:sp>
-        <p:nvSpPr>
-          <p:cNvPr id="7" name="TextBox 6"/>
-          <p:cNvSpPr txBox="1"/>
+      <p:graphicFrame>
+        <p:nvGraphicFramePr>
+          <p:cNvPr id="7" name="Table 6"/>
+          <p:cNvGraphicFramePr>
+            <a:graphicFrameLocks noGrp="1"/>
+          </p:cNvGraphicFramePr>
           <p:nvPr/>
-        </p:nvSpPr>
-        <p:spPr>
-          <a:xfrm>
-            <a:off x="5580000" y="1440000"/>
-            <a:ext cx="3960000" cy="1440000"/>
-          </a:xfrm>
-          <a:prstGeom prst="rect">
-            <a:avLst/>
-          </a:prstGeom>
-          <a:noFill/>
-        </p:spPr>
-        <p:txBody>
-          <a:bodyPr wrap="square">
-            <a:spAutoFit/>
-          </a:bodyPr>
-          <a:lstStyle/>
-          <a:p>
-            <a:r>
-              <a:rPr sz="1400" b="0">
-                <a:solidFill>
-                  <a:srgbClr val="94A3B8"/>
-                </a:solidFill>
-              </a:rPr>
-              <a:t>[table to be inserted after training]</a:t>
-            </a:r>
-          </a:p>
-        </p:txBody>
-      </p:sp>
+        </p:nvGraphicFramePr>
+        <p:xfrm>
+          <a:off x="5580000" y="1440000"/>
+          <a:ext cx="3960000" cy="1440000"/>
+        </p:xfrm>
+        <a:graphic>
+          <a:graphicData uri="http://schemas.openxmlformats.org/drawingml/2006/table">
+            <a:tbl>
+              <a:tblPr firstRow="1" bandRow="1">
+                <a:tableStyleId>{5C22544A-7EE6-4342-B048-85BDC9FD1C3A}</a:tableStyleId>
+              </a:tblPr>
+              <a:tblGrid>
+                <a:gridCol w="1980000"/>
+                <a:gridCol w="1980000"/>
+              </a:tblGrid>
+              <a:tr h="360000">
+                <a:tc>
+                  <a:txBody>
+                    <a:bodyPr wrap="square"/>
+                    <a:lstStyle/>
+                    <a:p>
+                      <a:r>
+                        <a:rPr sz="1100" b="1">
+                          <a:solidFill>
+                            <a:srgbClr val="F8FAFC"/>
+                          </a:solidFill>
+                        </a:rPr>
+                        <a:t>Variant</a:t>
+                      </a:r>
+                    </a:p>
+                  </a:txBody>
+                  <a:tcPr>
+                    <a:solidFill>
+                      <a:srgbClr val="1E293B"/>
+                    </a:solidFill>
+                  </a:tcPr>
+                </a:tc>
+                <a:tc>
+                  <a:txBody>
+                    <a:bodyPr wrap="square"/>
+                    <a:lstStyle/>
+                    <a:p>
+                      <a:r>
+                        <a:rPr sz="1100" b="1">
+                          <a:solidFill>
+                            <a:srgbClr val="F8FAFC"/>
+                          </a:solidFill>
+                        </a:rPr>
+                        <a:t>Accuracy</a:t>
+                      </a:r>
+                    </a:p>
+                  </a:txBody>
+                  <a:tcPr>
+                    <a:solidFill>
+                      <a:srgbClr val="1E293B"/>
+                    </a:solidFill>
+                  </a:tcPr>
+                </a:tc>
+              </a:tr>
+              <a:tr h="360000">
+                <a:tc>
+                  <a:txBody>
+                    <a:bodyPr wrap="square"/>
+                    <a:lstStyle/>
+                    <a:p>
+                      <a:r>
+                        <a:rPr sz="1100" b="0">
+                          <a:solidFill>
+                            <a:srgbClr val="F8FAFC"/>
+                          </a:solidFill>
+                        </a:rPr>
+                        <a:t>Landmark MLP (baseline)</a:t>
+                      </a:r>
+                    </a:p>
+                  </a:txBody>
+                  <a:tcPr>
+                    <a:solidFill>
+                      <a:srgbClr val="0F172A"/>
+                    </a:solidFill>
+                  </a:tcPr>
+                </a:tc>
+                <a:tc>
+                  <a:txBody>
+                    <a:bodyPr wrap="square"/>
+                    <a:lstStyle/>
+                    <a:p>
+                      <a:r>
+                        <a:rPr sz="1100" b="0">
+                          <a:solidFill>
+                            <a:srgbClr val="F8FAFC"/>
+                          </a:solidFill>
+                        </a:rPr>
+                        <a:t>0.9888</a:t>
+                      </a:r>
+                    </a:p>
+                  </a:txBody>
+                  <a:tcPr>
+                    <a:solidFill>
+                      <a:srgbClr val="0F172A"/>
+                    </a:solidFill>
+                  </a:tcPr>
+                </a:tc>
+              </a:tr>
+              <a:tr h="360000">
+                <a:tc>
+                  <a:txBody>
+                    <a:bodyPr wrap="square"/>
+                    <a:lstStyle/>
+                    <a:p>
+                      <a:r>
+                        <a:rPr sz="1100" b="0">
+                          <a:solidFill>
+                            <a:srgbClr val="F8FAFC"/>
+                          </a:solidFill>
+                        </a:rPr>
+                        <a:t>Landmark MLP (z=0)</a:t>
+                      </a:r>
+                    </a:p>
+                  </a:txBody>
+                  <a:tcPr>
+                    <a:solidFill>
+                      <a:srgbClr val="0F172A"/>
+                    </a:solidFill>
+                  </a:tcPr>
+                </a:tc>
+                <a:tc>
+                  <a:txBody>
+                    <a:bodyPr wrap="square"/>
+                    <a:lstStyle/>
+                    <a:p>
+                      <a:r>
+                        <a:rPr sz="1100" b="0">
+                          <a:solidFill>
+                            <a:srgbClr val="F8FAFC"/>
+                          </a:solidFill>
+                        </a:rPr>
+                        <a:t>0.9483</a:t>
+                      </a:r>
+                    </a:p>
+                  </a:txBody>
+                  <a:tcPr>
+                    <a:solidFill>
+                      <a:srgbClr val="0F172A"/>
+                    </a:solidFill>
+                  </a:tcPr>
+                </a:tc>
+              </a:tr>
+              <a:tr h="360000">
+                <a:tc>
+                  <a:txBody>
+                    <a:bodyPr wrap="square"/>
+                    <a:lstStyle/>
+                    <a:p>
+                      <a:r>
+                        <a:rPr sz="1100" b="0">
+                          <a:solidFill>
+                            <a:srgbClr val="F8FAFC"/>
+                          </a:solidFill>
+                        </a:rPr>
+                        <a:t>Landmark MLP + 3% noise</a:t>
+                      </a:r>
+                    </a:p>
+                  </a:txBody>
+                  <a:tcPr>
+                    <a:solidFill>
+                      <a:srgbClr val="0F172A"/>
+                    </a:solidFill>
+                  </a:tcPr>
+                </a:tc>
+                <a:tc>
+                  <a:txBody>
+                    <a:bodyPr wrap="square"/>
+                    <a:lstStyle/>
+                    <a:p>
+                      <a:r>
+                        <a:rPr sz="1100" b="0">
+                          <a:solidFill>
+                            <a:srgbClr val="F8FAFC"/>
+                          </a:solidFill>
+                        </a:rPr>
+                        <a:t>0.9839</a:t>
+                      </a:r>
+                    </a:p>
+                  </a:txBody>
+                  <a:tcPr>
+                    <a:solidFill>
+                      <a:srgbClr val="0F172A"/>
+                    </a:solidFill>
+                  </a:tcPr>
+                </a:tc>
+              </a:tr>
+            </a:tbl>
+          </a:graphicData>
+        </a:graphic>
+      </p:graphicFrame>
     </p:spTree>
   </p:cSld>
   <p:clrMapOvr>

</xml_diff>